<commit_message>
Relabel the PTT OR chart and show absolute figures in the bars
Renames the two rows to transaction count and transaction amount, and
puts absolute figures in the bar segments. A 100% stacked chart
normalises each category independently, so each row is pre-scaled to its
own unit - counts in millions, amounts in billions - which keeps the
proportions exact while the labels read naturally.

The Amazon/Oil split moves onto the row label so both the absolute and
the percentage stay visible; PowerPoint renders only one value per
segment.

Co-Authored-By: Claude Opus 5 <noreply@anthropic.com>
Claude-Session: https://claude.ai/code/session_01VKpfo226Go9vQJYa4eoC1d
</commit_message>
<xml_diff>
--- a/PTT_OR_Summary.pptx
+++ b/PTT_OR_Summary.pptx
@@ -133,7 +133,7 @@
                 </a:solidFill>
                 <a:latin typeface="Calibri"/>
               </a:rPr>
-              <a:t>Share of transactions and value</a:t>
+              <a:t>Transaction count and amount</a:t>
             </a:r>
           </a:p>
         </c:rich>
@@ -170,7 +170,7 @@
           </c:spPr>
           <c:invertIfNegative val="0"/>
           <c:dLbls>
-            <c:numFmt formatCode="0.0&quot;%&quot;" sourceLinked="0"/>
+            <c:numFmt formatCode="#,##0.00" sourceLinked="0"/>
             <c:txPr>
               <a:bodyPr/>
               <a:lstStyle/>
@@ -201,10 +201,10 @@
                 <c:ptCount val="2"/>
                 <c:lvl>
                   <c:pt idx="0">
-                    <c:v>Value  18.85B</c:v>
+                    <c:v>Transaction amount (B)   8% / 92%</c:v>
                   </c:pt>
                   <c:pt idx="1">
-                    <c:v>Transactions  40.78M</c:v>
+                    <c:v>Transaction count (M)   51% / 49%</c:v>
                   </c:pt>
                 </c:lvl>
               </c:multiLvlStrCache>
@@ -217,10 +217,10 @@
                 <c:formatCode>General</c:formatCode>
                 <c:ptCount val="2"/>
                 <c:pt idx="0">
-                  <c:v>8.4</c:v>
+                  <c:v>1.5889138</c:v>
                 </c:pt>
                 <c:pt idx="1">
-                  <c:v>51.2</c:v>
+                  <c:v>20.880784</c:v>
                 </c:pt>
               </c:numCache>
             </c:numRef>
@@ -248,7 +248,7 @@
           </c:spPr>
           <c:invertIfNegative val="0"/>
           <c:dLbls>
-            <c:numFmt formatCode="0.0&quot;%&quot;" sourceLinked="0"/>
+            <c:numFmt formatCode="#,##0.00" sourceLinked="0"/>
             <c:txPr>
               <a:bodyPr/>
               <a:lstStyle/>
@@ -279,10 +279,10 @@
                 <c:ptCount val="2"/>
                 <c:lvl>
                   <c:pt idx="0">
-                    <c:v>Value  18.85B</c:v>
+                    <c:v>Transaction amount (B)   8% / 92%</c:v>
                   </c:pt>
                   <c:pt idx="1">
-                    <c:v>Transactions  40.78M</c:v>
+                    <c:v>Transaction count (M)   51% / 49%</c:v>
                   </c:pt>
                 </c:lvl>
               </c:multiLvlStrCache>
@@ -295,17 +295,17 @@
                 <c:formatCode>General</c:formatCode>
                 <c:ptCount val="2"/>
                 <c:pt idx="0">
-                  <c:v>91.6</c:v>
+                  <c:v>17.2575913</c:v>
                 </c:pt>
                 <c:pt idx="1">
-                  <c:v>48.8</c:v>
+                  <c:v>19.900648</c:v>
                 </c:pt>
               </c:numCache>
             </c:numRef>
           </c:val>
         </c:ser>
         <c:dLbls>
-          <c:numFmt formatCode="0.0&quot;%&quot;" sourceLinked="0"/>
+          <c:numFmt formatCode="#,##0.00" sourceLinked="0"/>
           <c:txPr>
             <a:bodyPr/>
             <a:lstStyle/>
@@ -360,7 +360,7 @@
           <a:lstStyle/>
           <a:p>
             <a:pPr>
-              <a:defRPr sz="1050" b="0" i="0" u="none" strike="noStrike">
+              <a:defRPr sz="950" b="0" i="0" u="none" strike="noStrike">
                 <a:solidFill>
                   <a:srgbClr val="16233D"/>
                 </a:solidFill>
@@ -1716,7 +1716,7 @@
                 <a:ea typeface="Calibri" pitchFamily="34" charset="-122"/>
                 <a:cs typeface="Calibri" pitchFamily="34" charset="-120"/>
               </a:rPr>
-              <a:t>transactions</a:t>
+              <a:t>transaction count</a:t>
             </a:r>
             <a:endParaRPr lang="en-US" sz="1150" dirty="0"/>
           </a:p>
@@ -1855,7 +1855,7 @@
                 <a:ea typeface="Calibri" pitchFamily="34" charset="-122"/>
                 <a:cs typeface="Calibri" pitchFamily="34" charset="-120"/>
               </a:rPr>
-              <a:t>total value</a:t>
+              <a:t>transaction amount</a:t>
             </a:r>
             <a:endParaRPr lang="en-US" sz="1150" dirty="0"/>
           </a:p>
@@ -2517,7 +2517,7 @@
                 <a:ea typeface="Calibri" pitchFamily="34" charset="-122"/>
                 <a:cs typeface="Calibri" pitchFamily="34" charset="-120"/>
               </a:rPr>
-              <a:t>Source: figures as supplied, PTT OR, data as of Apr 2026; currency not stated. 'mtu amazon' and 'mtu oil' are read as single-brand users and 'mtu both' as the overlap — on that reading the three sum to 5,787,554 against the stated 5,785,346, a gap of 2,208 worth confirming. Per-user figures divide each brand's transactions by its total users, single-brand plus both. All percentages are computed from the supplied counts.</a:t>
+              <a:t>Source: figures as supplied, PTT OR, data as of Apr 2026; currency not stated. 'mtu amazon' and 'mtu oil' are read as single-brand users and 'mtu both' as the overlap — on that reading the three sum to 5,787,554 against the stated 5,785,346, a gap of 2,208 worth confirming. Bar labels are absolute figures in the unit named on each row — counts in millions, amounts in billions — and the pair beside each row label is the Amazon / Oil split. Per-user figures divide each brand's transactions by its total users, single-brand plus both. All percentages are computed from the supplied counts.</a:t>
             </a:r>
             <a:endParaRPr lang="en-US" sz="850" dirty="0"/>
           </a:p>

</xml_diff>